<commit_message>
Fix column widths so diagram boxes no longer overlap
The three- and four-column rows were sized from the content edge instead of
the content width, leaving a 0.1in overlap between neighbouring boxes.

🤖 Generated with Codebuff
Co-Authored-By: Codebuff <noreply@codebuff.com>
</commit_message>
<xml_diff>
--- a/prometheus-architecture-fa.pptx
+++ b/prometheus-architecture-fa.pptx
@@ -3285,8 +3285,8 @@
         </p:nvSpPr>
         <p:spPr>
           <a:xfrm>
-            <a:off x="6918960" y="4160520"/>
-            <a:ext cx="3139440" cy="960120"/>
+            <a:off x="7056120" y="4160520"/>
+            <a:ext cx="3002280" cy="960120"/>
           </a:xfrm>
           <a:prstGeom prst="roundRect">
             <a:avLst>
@@ -3380,8 +3380,8 @@
         </p:nvSpPr>
         <p:spPr>
           <a:xfrm>
-            <a:off x="3459479" y="4160520"/>
-            <a:ext cx="3139440" cy="960120"/>
+            <a:off x="3733799" y="4160520"/>
+            <a:ext cx="3002280" cy="960120"/>
           </a:xfrm>
           <a:prstGeom prst="roundRect">
             <a:avLst>
@@ -3475,8 +3475,8 @@
         </p:nvSpPr>
         <p:spPr>
           <a:xfrm>
-            <a:off x="411480" y="4160520"/>
-            <a:ext cx="3139440" cy="960120"/>
+            <a:off x="411479" y="4160520"/>
+            <a:ext cx="3002280" cy="960120"/>
           </a:xfrm>
           <a:prstGeom prst="roundRect">
             <a:avLst>
@@ -3729,8 +3729,8 @@
         </p:nvSpPr>
         <p:spPr>
           <a:xfrm>
-            <a:off x="6918960" y="1691640"/>
-            <a:ext cx="3139440" cy="2743200"/>
+            <a:off x="7056120" y="1691640"/>
+            <a:ext cx="3002280" cy="2743200"/>
           </a:xfrm>
           <a:prstGeom prst="roundRect">
             <a:avLst>
@@ -3896,8 +3896,8 @@
         </p:nvSpPr>
         <p:spPr>
           <a:xfrm>
-            <a:off x="3459479" y="1691640"/>
-            <a:ext cx="3139440" cy="2743200"/>
+            <a:off x="3733799" y="1691640"/>
+            <a:ext cx="3002280" cy="2743200"/>
           </a:xfrm>
           <a:prstGeom prst="roundRect">
             <a:avLst>
@@ -4063,8 +4063,8 @@
         </p:nvSpPr>
         <p:spPr>
           <a:xfrm>
-            <a:off x="411480" y="1691640"/>
-            <a:ext cx="3139440" cy="2743200"/>
+            <a:off x="411479" y="1691640"/>
+            <a:ext cx="3002280" cy="2743200"/>
           </a:xfrm>
           <a:prstGeom prst="roundRect">
             <a:avLst>
@@ -4230,7 +4230,7 @@
         </p:nvCxnSpPr>
         <p:spPr>
           <a:xfrm flipH="1">
-            <a:off x="6598920" y="3063240"/>
+            <a:off x="6736080" y="3063240"/>
             <a:ext cx="320040" cy="0"/>
           </a:xfrm>
           <a:prstGeom prst="line">
@@ -4265,9 +4265,9 @@
           <p:nvPr/>
         </p:nvCxnSpPr>
         <p:spPr>
-          <a:xfrm>
-            <a:off x="3459479" y="3063240"/>
-            <a:ext cx="91441" cy="0"/>
+          <a:xfrm flipH="1">
+            <a:off x="3413759" y="3063240"/>
+            <a:ext cx="320040" cy="0"/>
           </a:xfrm>
           <a:prstGeom prst="line">
             <a:avLst/>
@@ -4624,8 +4624,8 @@
         </p:nvSpPr>
         <p:spPr>
           <a:xfrm>
-            <a:off x="7783829" y="1371600"/>
-            <a:ext cx="2274570" cy="1554480"/>
+            <a:off x="7886700" y="1371600"/>
+            <a:ext cx="2171700" cy="1554480"/>
           </a:xfrm>
           <a:prstGeom prst="roundRect">
             <a:avLst>
@@ -4767,8 +4767,8 @@
         </p:nvSpPr>
         <p:spPr>
           <a:xfrm>
-            <a:off x="5189220" y="1371600"/>
-            <a:ext cx="2274570" cy="1554480"/>
+            <a:off x="5394960" y="1371600"/>
+            <a:ext cx="2171700" cy="1554480"/>
           </a:xfrm>
           <a:prstGeom prst="roundRect">
             <a:avLst>
@@ -4910,8 +4910,8 @@
         </p:nvSpPr>
         <p:spPr>
           <a:xfrm>
-            <a:off x="2594610" y="1371600"/>
-            <a:ext cx="2274570" cy="1554480"/>
+            <a:off x="2903220" y="1371600"/>
+            <a:ext cx="2171700" cy="1554480"/>
           </a:xfrm>
           <a:prstGeom prst="roundRect">
             <a:avLst>
@@ -5053,8 +5053,8 @@
         </p:nvSpPr>
         <p:spPr>
           <a:xfrm>
-            <a:off x="411480" y="1371600"/>
-            <a:ext cx="2274570" cy="1554480"/>
+            <a:off x="411479" y="1371600"/>
+            <a:ext cx="2171700" cy="1554480"/>
           </a:xfrm>
           <a:prstGeom prst="roundRect">
             <a:avLst>
@@ -5196,8 +5196,8 @@
         </p:nvCxnSpPr>
         <p:spPr>
           <a:xfrm flipH="1">
-            <a:off x="7463790" y="2148840"/>
-            <a:ext cx="320039" cy="0"/>
+            <a:off x="7566660" y="2148840"/>
+            <a:ext cx="320040" cy="0"/>
           </a:xfrm>
           <a:prstGeom prst="line">
             <a:avLst/>
@@ -5232,7 +5232,7 @@
         </p:nvCxnSpPr>
         <p:spPr>
           <a:xfrm flipH="1">
-            <a:off x="4869180" y="2148840"/>
+            <a:off x="5074920" y="2148840"/>
             <a:ext cx="320040" cy="0"/>
           </a:xfrm>
           <a:prstGeom prst="line">
@@ -5267,9 +5267,9 @@
           <p:nvPr/>
         </p:nvCxnSpPr>
         <p:spPr>
-          <a:xfrm>
-            <a:off x="2594610" y="2148840"/>
-            <a:ext cx="91440" cy="0"/>
+          <a:xfrm flipH="1">
+            <a:off x="2583179" y="2148840"/>
+            <a:ext cx="320041" cy="0"/>
           </a:xfrm>
           <a:prstGeom prst="line">
             <a:avLst/>
@@ -5304,8 +5304,8 @@
         </p:nvSpPr>
         <p:spPr>
           <a:xfrm>
-            <a:off x="5189220" y="3520440"/>
-            <a:ext cx="2274570" cy="1554480"/>
+            <a:off x="5394960" y="3520440"/>
+            <a:ext cx="2171700" cy="1554480"/>
           </a:xfrm>
           <a:prstGeom prst="roundRect">
             <a:avLst>
@@ -5447,8 +5447,8 @@
         </p:nvSpPr>
         <p:spPr>
           <a:xfrm>
-            <a:off x="2594610" y="3520440"/>
-            <a:ext cx="2274570" cy="1554480"/>
+            <a:off x="2903220" y="3520440"/>
+            <a:ext cx="2171700" cy="1554480"/>
           </a:xfrm>
           <a:prstGeom prst="roundRect">
             <a:avLst>
@@ -5590,8 +5590,8 @@
         </p:nvSpPr>
         <p:spPr>
           <a:xfrm>
-            <a:off x="411480" y="3520440"/>
-            <a:ext cx="2274570" cy="1554480"/>
+            <a:off x="411479" y="3520440"/>
+            <a:ext cx="2171700" cy="1554480"/>
           </a:xfrm>
           <a:prstGeom prst="roundRect">
             <a:avLst>
@@ -5733,7 +5733,7 @@
         </p:nvCxnSpPr>
         <p:spPr>
           <a:xfrm>
-            <a:off x="6326505" y="2926080"/>
+            <a:off x="6480810" y="2926080"/>
             <a:ext cx="0" cy="594360"/>
           </a:xfrm>
           <a:prstGeom prst="line">
@@ -5769,7 +5769,7 @@
         </p:nvCxnSpPr>
         <p:spPr>
           <a:xfrm>
-            <a:off x="3731895" y="2926080"/>
+            <a:off x="3989070" y="2926080"/>
             <a:ext cx="0" cy="594360"/>
           </a:xfrm>
           <a:prstGeom prst="line">
@@ -5805,7 +5805,7 @@
         </p:nvCxnSpPr>
         <p:spPr>
           <a:xfrm>
-            <a:off x="1548764" y="2926080"/>
+            <a:off x="1497329" y="2926080"/>
             <a:ext cx="0" cy="594360"/>
           </a:xfrm>
           <a:prstGeom prst="line">
@@ -5841,8 +5841,8 @@
         </p:nvSpPr>
         <p:spPr>
           <a:xfrm>
-            <a:off x="7783829" y="3520440"/>
-            <a:ext cx="2274570" cy="1554480"/>
+            <a:off x="7886700" y="3520440"/>
+            <a:ext cx="2171700" cy="1554480"/>
           </a:xfrm>
           <a:prstGeom prst="roundRect">
             <a:avLst>
@@ -6231,7 +6231,7 @@
         </p:nvSpPr>
         <p:spPr>
           <a:xfrm>
-            <a:off x="2468880" y="1371600"/>
+            <a:off x="2674620" y="1371600"/>
             <a:ext cx="5120640" cy="914400"/>
           </a:xfrm>
           <a:prstGeom prst="roundRect">
@@ -6350,8 +6350,8 @@
         </p:nvSpPr>
         <p:spPr>
           <a:xfrm>
-            <a:off x="6918960" y="2743200"/>
-            <a:ext cx="3139440" cy="1554480"/>
+            <a:off x="7056120" y="2743200"/>
+            <a:ext cx="3002280" cy="1554480"/>
           </a:xfrm>
           <a:prstGeom prst="roundRect">
             <a:avLst>
@@ -6493,8 +6493,8 @@
         </p:nvSpPr>
         <p:spPr>
           <a:xfrm>
-            <a:off x="3459479" y="2743200"/>
-            <a:ext cx="3139440" cy="1554480"/>
+            <a:off x="3733799" y="2743200"/>
+            <a:ext cx="3002280" cy="1554480"/>
           </a:xfrm>
           <a:prstGeom prst="roundRect">
             <a:avLst>
@@ -6636,8 +6636,8 @@
         </p:nvSpPr>
         <p:spPr>
           <a:xfrm>
-            <a:off x="411480" y="2743200"/>
-            <a:ext cx="3139440" cy="1554480"/>
+            <a:off x="411479" y="2743200"/>
+            <a:ext cx="3002280" cy="1554480"/>
           </a:xfrm>
           <a:prstGeom prst="roundRect">
             <a:avLst>
@@ -6779,8 +6779,8 @@
         </p:nvCxnSpPr>
         <p:spPr>
           <a:xfrm>
-            <a:off x="5349240" y="2286000"/>
-            <a:ext cx="3139440" cy="457200"/>
+            <a:off x="5554979" y="2286000"/>
+            <a:ext cx="3002281" cy="457200"/>
           </a:xfrm>
           <a:prstGeom prst="line">
             <a:avLst/>
@@ -6815,7 +6815,7 @@
         </p:nvCxnSpPr>
         <p:spPr>
           <a:xfrm>
-            <a:off x="5029200" y="2286000"/>
+            <a:off x="5234940" y="2286000"/>
             <a:ext cx="0" cy="457200"/>
           </a:xfrm>
           <a:prstGeom prst="line">
@@ -6851,8 +6851,8 @@
         </p:nvCxnSpPr>
         <p:spPr>
           <a:xfrm flipH="1">
-            <a:off x="1981200" y="2286000"/>
-            <a:ext cx="2727960" cy="457200"/>
+            <a:off x="1912619" y="2286000"/>
+            <a:ext cx="3002281" cy="457200"/>
           </a:xfrm>
           <a:prstGeom prst="line">
             <a:avLst/>
@@ -6887,8 +6887,8 @@
         </p:nvSpPr>
         <p:spPr>
           <a:xfrm>
-            <a:off x="3459479" y="4663440"/>
-            <a:ext cx="6598920" cy="1234440"/>
+            <a:off x="3733799" y="4663440"/>
+            <a:ext cx="6324600" cy="1234440"/>
           </a:xfrm>
           <a:prstGeom prst="roundRect">
             <a:avLst>
@@ -7006,8 +7006,8 @@
         </p:nvSpPr>
         <p:spPr>
           <a:xfrm>
-            <a:off x="411480" y="4663440"/>
-            <a:ext cx="3139440" cy="1234440"/>
+            <a:off x="411479" y="4663440"/>
+            <a:ext cx="3002280" cy="1234440"/>
           </a:xfrm>
           <a:prstGeom prst="roundRect">
             <a:avLst>
@@ -7125,7 +7125,7 @@
         </p:nvCxnSpPr>
         <p:spPr>
           <a:xfrm>
-            <a:off x="8488680" y="4297680"/>
+            <a:off x="8557260" y="4297680"/>
             <a:ext cx="0" cy="365760"/>
           </a:xfrm>
           <a:prstGeom prst="line">
@@ -7161,7 +7161,7 @@
         </p:nvCxnSpPr>
         <p:spPr>
           <a:xfrm>
-            <a:off x="5029200" y="4297680"/>
+            <a:off x="5234940" y="4297680"/>
             <a:ext cx="0" cy="365760"/>
           </a:xfrm>
           <a:prstGeom prst="line">
@@ -7197,7 +7197,7 @@
         </p:nvCxnSpPr>
         <p:spPr>
           <a:xfrm>
-            <a:off x="1981200" y="4297680"/>
+            <a:off x="1912619" y="4297680"/>
             <a:ext cx="0" cy="365760"/>
           </a:xfrm>
           <a:prstGeom prst="line">
@@ -7232,9 +7232,9 @@
           <p:nvPr/>
         </p:nvCxnSpPr>
         <p:spPr>
-          <a:xfrm>
-            <a:off x="3459479" y="5280659"/>
-            <a:ext cx="91441" cy="0"/>
+          <a:xfrm flipH="1">
+            <a:off x="3413759" y="5280659"/>
+            <a:ext cx="320040" cy="0"/>
           </a:xfrm>
           <a:prstGeom prst="line">
             <a:avLst/>
@@ -7519,8 +7519,8 @@
         </p:nvSpPr>
         <p:spPr>
           <a:xfrm>
-            <a:off x="6918960" y="1325880"/>
-            <a:ext cx="3139440" cy="777240"/>
+            <a:off x="7056120" y="1325880"/>
+            <a:ext cx="3002280" cy="777240"/>
           </a:xfrm>
           <a:prstGeom prst="roundRect">
             <a:avLst>
@@ -7638,8 +7638,8 @@
         </p:nvSpPr>
         <p:spPr>
           <a:xfrm>
-            <a:off x="3459479" y="1325880"/>
-            <a:ext cx="3139440" cy="777240"/>
+            <a:off x="3733799" y="1325880"/>
+            <a:ext cx="3002280" cy="777240"/>
           </a:xfrm>
           <a:prstGeom prst="roundRect">
             <a:avLst>
@@ -7757,8 +7757,8 @@
         </p:nvSpPr>
         <p:spPr>
           <a:xfrm>
-            <a:off x="411480" y="1325880"/>
-            <a:ext cx="3139440" cy="777240"/>
+            <a:off x="411479" y="1325880"/>
+            <a:ext cx="3002280" cy="777240"/>
           </a:xfrm>
           <a:prstGeom prst="roundRect">
             <a:avLst>
@@ -7876,8 +7876,8 @@
         </p:nvSpPr>
         <p:spPr>
           <a:xfrm>
-            <a:off x="6918960" y="2377440"/>
-            <a:ext cx="3139440" cy="960120"/>
+            <a:off x="7056120" y="2377440"/>
+            <a:ext cx="3002280" cy="960120"/>
           </a:xfrm>
           <a:prstGeom prst="roundRect">
             <a:avLst>
@@ -8019,8 +8019,8 @@
         </p:nvSpPr>
         <p:spPr>
           <a:xfrm>
-            <a:off x="3459479" y="2377440"/>
-            <a:ext cx="3139440" cy="960120"/>
+            <a:off x="3733799" y="2377440"/>
+            <a:ext cx="3002280" cy="960120"/>
           </a:xfrm>
           <a:prstGeom prst="roundRect">
             <a:avLst>
@@ -8162,8 +8162,8 @@
         </p:nvSpPr>
         <p:spPr>
           <a:xfrm>
-            <a:off x="411480" y="2377440"/>
-            <a:ext cx="3139440" cy="960120"/>
+            <a:off x="411479" y="2377440"/>
+            <a:ext cx="3002280" cy="960120"/>
           </a:xfrm>
           <a:prstGeom prst="roundRect">
             <a:avLst>
@@ -8305,7 +8305,7 @@
         </p:nvCxnSpPr>
         <p:spPr>
           <a:xfrm>
-            <a:off x="8488680" y="2103120"/>
+            <a:off x="8557260" y="2103120"/>
             <a:ext cx="0" cy="274320"/>
           </a:xfrm>
           <a:prstGeom prst="line">
@@ -8341,7 +8341,7 @@
         </p:nvCxnSpPr>
         <p:spPr>
           <a:xfrm>
-            <a:off x="5029200" y="2103120"/>
+            <a:off x="5234940" y="2103120"/>
             <a:ext cx="0" cy="274320"/>
           </a:xfrm>
           <a:prstGeom prst="line">
@@ -8377,7 +8377,7 @@
         </p:nvCxnSpPr>
         <p:spPr>
           <a:xfrm>
-            <a:off x="1981200" y="2103120"/>
+            <a:off x="1912619" y="2103120"/>
             <a:ext cx="0" cy="274320"/>
           </a:xfrm>
           <a:prstGeom prst="line">
@@ -8413,8 +8413,8 @@
         </p:nvSpPr>
         <p:spPr>
           <a:xfrm>
-            <a:off x="3459479" y="3611880"/>
-            <a:ext cx="6598920" cy="822960"/>
+            <a:off x="3733799" y="3611880"/>
+            <a:ext cx="6324600" cy="822960"/>
           </a:xfrm>
           <a:prstGeom prst="roundRect">
             <a:avLst>
@@ -8532,8 +8532,8 @@
         </p:nvSpPr>
         <p:spPr>
           <a:xfrm>
-            <a:off x="411480" y="3611880"/>
-            <a:ext cx="3139440" cy="822960"/>
+            <a:off x="411479" y="3611880"/>
+            <a:ext cx="3002280" cy="822960"/>
           </a:xfrm>
           <a:prstGeom prst="roundRect">
             <a:avLst>
@@ -8651,7 +8651,7 @@
         </p:nvCxnSpPr>
         <p:spPr>
           <a:xfrm>
-            <a:off x="8488680" y="3337560"/>
+            <a:off x="8557260" y="3337560"/>
             <a:ext cx="0" cy="274320"/>
           </a:xfrm>
           <a:prstGeom prst="line">
@@ -8687,7 +8687,7 @@
         </p:nvCxnSpPr>
         <p:spPr>
           <a:xfrm>
-            <a:off x="5029200" y="3337560"/>
+            <a:off x="5234940" y="3337560"/>
             <a:ext cx="0" cy="274320"/>
           </a:xfrm>
           <a:prstGeom prst="line">
@@ -8723,7 +8723,7 @@
         </p:nvCxnSpPr>
         <p:spPr>
           <a:xfrm>
-            <a:off x="1981200" y="3337560"/>
+            <a:off x="1912619" y="3337560"/>
             <a:ext cx="0" cy="274320"/>
           </a:xfrm>
           <a:prstGeom prst="line">
@@ -8854,7 +8854,7 @@
         </p:nvCxnSpPr>
         <p:spPr>
           <a:xfrm>
-            <a:off x="9494520" y="4434840"/>
+            <a:off x="9563100" y="4434840"/>
             <a:ext cx="0" cy="274320"/>
           </a:xfrm>
           <a:prstGeom prst="line">
@@ -8890,7 +8890,7 @@
         </p:nvCxnSpPr>
         <p:spPr>
           <a:xfrm>
-            <a:off x="1981200" y="4434840"/>
+            <a:off x="1912619" y="4434840"/>
             <a:ext cx="0" cy="274320"/>
           </a:xfrm>
           <a:prstGeom prst="line">
@@ -8926,8 +8926,8 @@
         </p:nvSpPr>
         <p:spPr>
           <a:xfrm>
-            <a:off x="7852410" y="5669280"/>
-            <a:ext cx="2205990" cy="777240"/>
+            <a:off x="7818120" y="5669280"/>
+            <a:ext cx="2240280" cy="777240"/>
           </a:xfrm>
           <a:prstGeom prst="roundRect">
             <a:avLst>
@@ -9045,8 +9045,8 @@
         </p:nvSpPr>
         <p:spPr>
           <a:xfrm>
-            <a:off x="5417820" y="5669280"/>
-            <a:ext cx="2205990" cy="777240"/>
+            <a:off x="5349240" y="5669280"/>
+            <a:ext cx="2240280" cy="777240"/>
           </a:xfrm>
           <a:prstGeom prst="roundRect">
             <a:avLst>
@@ -9164,8 +9164,8 @@
         </p:nvSpPr>
         <p:spPr>
           <a:xfrm>
-            <a:off x="2983229" y="5669280"/>
-            <a:ext cx="2205990" cy="777240"/>
+            <a:off x="2880359" y="5669280"/>
+            <a:ext cx="2240280" cy="777240"/>
           </a:xfrm>
           <a:prstGeom prst="roundRect">
             <a:avLst>
@@ -9283,8 +9283,8 @@
         </p:nvSpPr>
         <p:spPr>
           <a:xfrm>
-            <a:off x="548639" y="5669280"/>
-            <a:ext cx="2205990" cy="777240"/>
+            <a:off x="411479" y="5669280"/>
+            <a:ext cx="2240280" cy="777240"/>
           </a:xfrm>
           <a:prstGeom prst="roundRect">
             <a:avLst>
@@ -9402,7 +9402,7 @@
         </p:nvCxnSpPr>
         <p:spPr>
           <a:xfrm>
-            <a:off x="8955405" y="5394960"/>
+            <a:off x="8938260" y="5394960"/>
             <a:ext cx="0" cy="274320"/>
           </a:xfrm>
           <a:prstGeom prst="line">
@@ -9438,7 +9438,7 @@
         </p:nvCxnSpPr>
         <p:spPr>
           <a:xfrm>
-            <a:off x="6520815" y="5394960"/>
+            <a:off x="6469379" y="5394960"/>
             <a:ext cx="0" cy="274320"/>
           </a:xfrm>
           <a:prstGeom prst="line">
@@ -9474,7 +9474,7 @@
         </p:nvCxnSpPr>
         <p:spPr>
           <a:xfrm>
-            <a:off x="4086224" y="5394960"/>
+            <a:off x="4000500" y="5394960"/>
             <a:ext cx="0" cy="274320"/>
           </a:xfrm>
           <a:prstGeom prst="line">
@@ -9510,7 +9510,7 @@
         </p:nvCxnSpPr>
         <p:spPr>
           <a:xfrm>
-            <a:off x="1651634" y="5394960"/>
+            <a:off x="1531619" y="5394960"/>
             <a:ext cx="0" cy="274320"/>
           </a:xfrm>
           <a:prstGeom prst="line">

</xml_diff>